<commit_message>
sistemas de Gestion UD5 caso practico empezado
</commit_message>
<xml_diff>
--- a/Asignaturas 2/Proyecto Intermodular/Presentacion/version Final 3/Muñoz_de_la_Sierra_Alejandro_Proyecto_Intermodular_Presentacion_Final.pptx
+++ b/Asignaturas 2/Proyecto Intermodular/Presentacion/version Final 3/Muñoz_de_la_Sierra_Alejandro_Proyecto_Intermodular_Presentacion_Final.pptx
@@ -12060,13 +12060,13 @@
   <p:clrMapOvr>
     <a:masterClrMapping/>
   </p:clrMapOvr>
-  <mc:AlternateContent xmlns:mc="http://schemas.openxmlformats.org/markup-compatibility/2006">
-    <mc:Choice xmlns:p14="http://schemas.microsoft.com/office/powerpoint/2010/main" Requires="p14">
+  <mc:AlternateContent xmlns:mc="http://schemas.openxmlformats.org/markup-compatibility/2006" xmlns:p14="http://schemas.microsoft.com/office/powerpoint/2010/main">
+    <mc:Choice Requires="p14">
       <p:transition spd="med" p14:dur="700">
         <p:fade/>
       </p:transition>
     </mc:Choice>
-    <mc:Fallback>
+    <mc:Fallback xmlns="">
       <p:transition spd="med">
         <p:fade/>
       </p:transition>
@@ -12879,13 +12879,13 @@
   <p:clrMapOvr>
     <a:masterClrMapping/>
   </p:clrMapOvr>
-  <mc:AlternateContent xmlns:mc="http://schemas.openxmlformats.org/markup-compatibility/2006">
-    <mc:Choice xmlns:p14="http://schemas.microsoft.com/office/powerpoint/2010/main" Requires="p14">
+  <mc:AlternateContent xmlns:mc="http://schemas.openxmlformats.org/markup-compatibility/2006" xmlns:p14="http://schemas.microsoft.com/office/powerpoint/2010/main">
+    <mc:Choice Requires="p14">
       <p:transition spd="med" p14:dur="700">
         <p:fade/>
       </p:transition>
     </mc:Choice>
-    <mc:Fallback>
+    <mc:Fallback xmlns="">
       <p:transition spd="med">
         <p:fade/>
       </p:transition>
@@ -13073,13 +13073,13 @@
   <p:clrMapOvr>
     <a:masterClrMapping/>
   </p:clrMapOvr>
-  <mc:AlternateContent xmlns:mc="http://schemas.openxmlformats.org/markup-compatibility/2006">
-    <mc:Choice xmlns:p14="http://schemas.microsoft.com/office/powerpoint/2010/main" Requires="p14">
+  <mc:AlternateContent xmlns:mc="http://schemas.openxmlformats.org/markup-compatibility/2006" xmlns:p14="http://schemas.microsoft.com/office/powerpoint/2010/main">
+    <mc:Choice Requires="p14">
       <p:transition spd="med" p14:dur="700">
         <p:fade/>
       </p:transition>
     </mc:Choice>
-    <mc:Fallback>
+    <mc:Fallback xmlns="">
       <p:transition spd="med">
         <p:fade/>
       </p:transition>
@@ -13969,13 +13969,13 @@
   <p:clrMapOvr>
     <a:masterClrMapping/>
   </p:clrMapOvr>
-  <mc:AlternateContent xmlns:mc="http://schemas.openxmlformats.org/markup-compatibility/2006">
-    <mc:Choice xmlns:p14="http://schemas.microsoft.com/office/powerpoint/2010/main" Requires="p14">
+  <mc:AlternateContent xmlns:mc="http://schemas.openxmlformats.org/markup-compatibility/2006" xmlns:p14="http://schemas.microsoft.com/office/powerpoint/2010/main">
+    <mc:Choice Requires="p14">
       <p:transition spd="med" p14:dur="700">
         <p:fade/>
       </p:transition>
     </mc:Choice>
-    <mc:Fallback>
+    <mc:Fallback xmlns="">
       <p:transition spd="med">
         <p:fade/>
       </p:transition>
@@ -15027,7 +15027,7 @@
         <p:spPr>
           <a:xfrm>
             <a:off x="8388250" y="3305323"/>
-            <a:ext cx="3073665" cy="314325"/>
+            <a:ext cx="3073665" cy="507831"/>
           </a:xfrm>
           <a:prstGeom prst="rect">
             <a:avLst/>
@@ -15053,7 +15053,7 @@
               <a:buNone/>
             </a:pPr>
             <a:r>
-              <a:rPr lang="en-US" sz="1650" b="1" i="0" u="none" strike="noStrike" cap="none">
+              <a:rPr lang="en-US" sz="1650" b="1" i="0" u="none" strike="noStrike" cap="none" dirty="0">
                 <a:solidFill>
                   <a:srgbClr val="F8FAFC"/>
                 </a:solidFill>
@@ -15062,9 +15062,33 @@
                 <a:cs typeface="Poppins"/>
                 <a:sym typeface="Poppins"/>
               </a:rPr>
-              <a:t>BD: MySQL 8 &amp; Hibernate</a:t>
-            </a:r>
-            <a:endParaRPr/>
+              <a:t>BD: </a:t>
+            </a:r>
+            <a:r>
+              <a:rPr lang="en-US" sz="1650" b="1" i="0" u="none" strike="noStrike" cap="none" dirty="0" err="1">
+                <a:solidFill>
+                  <a:srgbClr val="F8FAFC"/>
+                </a:solidFill>
+                <a:latin typeface="Poppins"/>
+                <a:ea typeface="Poppins"/>
+                <a:cs typeface="Poppins"/>
+                <a:sym typeface="Poppins"/>
+              </a:rPr>
+              <a:t>MariaDb</a:t>
+            </a:r>
+            <a:r>
+              <a:rPr lang="en-US" sz="1650" b="1" i="0" u="none" strike="noStrike" cap="none" dirty="0">
+                <a:solidFill>
+                  <a:srgbClr val="F8FAFC"/>
+                </a:solidFill>
+                <a:latin typeface="Poppins"/>
+                <a:ea typeface="Poppins"/>
+                <a:cs typeface="Poppins"/>
+                <a:sym typeface="Poppins"/>
+              </a:rPr>
+              <a:t> 10 (MySQL 8) &amp; Hibernate</a:t>
+            </a:r>
+            <a:endParaRPr dirty="0"/>
           </a:p>
         </p:txBody>
       </p:sp>
@@ -15077,7 +15101,7 @@
         <p:spPr>
           <a:xfrm>
             <a:off x="8388250" y="3762523"/>
-            <a:ext cx="2927300" cy="1736824"/>
+            <a:ext cx="2927300" cy="2105192"/>
           </a:xfrm>
           <a:prstGeom prst="rect">
             <a:avLst/>
@@ -15106,7 +15130,7 @@
               <a:buNone/>
             </a:pPr>
             <a:r>
-              <a:rPr lang="en-US" sz="1425" b="0" i="0" u="none" strike="noStrike" cap="none">
+              <a:rPr lang="en-US" sz="1425" b="0" i="0" u="none" strike="noStrike" cap="none" dirty="0">
                 <a:solidFill>
                   <a:srgbClr val="F8FAFC"/>
                 </a:solidFill>
@@ -15115,10 +15139,34 @@
                 <a:cs typeface="Inter SemiBold"/>
                 <a:sym typeface="Inter SemiBold"/>
               </a:rPr>
-              <a:t>¿Por qué?</a:t>
-            </a:r>
-            <a:r>
-              <a:rPr lang="en-US" sz="1425" b="0" i="0" u="none" strike="noStrike" cap="none">
+              <a:t>¿Por </a:t>
+            </a:r>
+            <a:r>
+              <a:rPr lang="en-US" sz="1425" b="0" i="0" u="none" strike="noStrike" cap="none" dirty="0" err="1">
+                <a:solidFill>
+                  <a:srgbClr val="F8FAFC"/>
+                </a:solidFill>
+                <a:latin typeface="Inter SemiBold"/>
+                <a:ea typeface="Inter SemiBold"/>
+                <a:cs typeface="Inter SemiBold"/>
+                <a:sym typeface="Inter SemiBold"/>
+              </a:rPr>
+              <a:t>qué</a:t>
+            </a:r>
+            <a:r>
+              <a:rPr lang="en-US" sz="1425" b="0" i="0" u="none" strike="noStrike" cap="none" dirty="0">
+                <a:solidFill>
+                  <a:srgbClr val="F8FAFC"/>
+                </a:solidFill>
+                <a:latin typeface="Inter SemiBold"/>
+                <a:ea typeface="Inter SemiBold"/>
+                <a:cs typeface="Inter SemiBold"/>
+                <a:sym typeface="Inter SemiBold"/>
+              </a:rPr>
+              <a:t>?</a:t>
+            </a:r>
+            <a:r>
+              <a:rPr lang="en-US" sz="1425" b="0" i="0" u="none" strike="noStrike" cap="none" dirty="0">
                 <a:solidFill>
                   <a:srgbClr val="94A3B8"/>
                 </a:solidFill>
@@ -15127,9 +15175,273 @@
                 <a:cs typeface="Inter"/>
                 <a:sym typeface="Inter"/>
               </a:rPr>
-              <a:t> MySQL asegura integridad relacional (ACID). Hibernate mapea nuestros objetos Java a tablas SQL automáticamente, ahorrando código repetitivo (Boilerplate).</a:t>
-            </a:r>
-            <a:endParaRPr/>
+              <a:t> MariaDB </a:t>
+            </a:r>
+            <a:r>
+              <a:rPr lang="en-US" sz="1425" b="0" i="0" u="none" strike="noStrike" cap="none" dirty="0" err="1">
+                <a:solidFill>
+                  <a:srgbClr val="94A3B8"/>
+                </a:solidFill>
+                <a:latin typeface="Inter"/>
+                <a:ea typeface="Inter"/>
+                <a:cs typeface="Inter"/>
+                <a:sym typeface="Inter"/>
+              </a:rPr>
+              <a:t>asegura</a:t>
+            </a:r>
+            <a:r>
+              <a:rPr lang="en-US" sz="1425" b="0" i="0" u="none" strike="noStrike" cap="none" dirty="0">
+                <a:solidFill>
+                  <a:srgbClr val="94A3B8"/>
+                </a:solidFill>
+                <a:latin typeface="Inter"/>
+                <a:ea typeface="Inter"/>
+                <a:cs typeface="Inter"/>
+                <a:sym typeface="Inter"/>
+              </a:rPr>
+              <a:t> </a:t>
+            </a:r>
+            <a:r>
+              <a:rPr lang="en-US" sz="1425" b="0" i="0" u="none" strike="noStrike" cap="none" dirty="0" err="1">
+                <a:solidFill>
+                  <a:srgbClr val="94A3B8"/>
+                </a:solidFill>
+                <a:latin typeface="Inter"/>
+                <a:ea typeface="Inter"/>
+                <a:cs typeface="Inter"/>
+                <a:sym typeface="Inter"/>
+              </a:rPr>
+              <a:t>integridad</a:t>
+            </a:r>
+            <a:r>
+              <a:rPr lang="en-US" sz="1425" b="0" i="0" u="none" strike="noStrike" cap="none" dirty="0">
+                <a:solidFill>
+                  <a:srgbClr val="94A3B8"/>
+                </a:solidFill>
+                <a:latin typeface="Inter"/>
+                <a:ea typeface="Inter"/>
+                <a:cs typeface="Inter"/>
+                <a:sym typeface="Inter"/>
+              </a:rPr>
+              <a:t> </a:t>
+            </a:r>
+            <a:r>
+              <a:rPr lang="en-US" sz="1425" b="0" i="0" u="none" strike="noStrike" cap="none" dirty="0" err="1">
+                <a:solidFill>
+                  <a:srgbClr val="94A3B8"/>
+                </a:solidFill>
+                <a:latin typeface="Inter"/>
+                <a:ea typeface="Inter"/>
+                <a:cs typeface="Inter"/>
+                <a:sym typeface="Inter"/>
+              </a:rPr>
+              <a:t>relacional</a:t>
+            </a:r>
+            <a:r>
+              <a:rPr lang="en-US" sz="1425" b="0" i="0" u="none" strike="noStrike" cap="none" dirty="0">
+                <a:solidFill>
+                  <a:srgbClr val="94A3B8"/>
+                </a:solidFill>
+                <a:latin typeface="Inter"/>
+                <a:ea typeface="Inter"/>
+                <a:cs typeface="Inter"/>
+                <a:sym typeface="Inter"/>
+              </a:rPr>
+              <a:t> (ACID). Hibernate </a:t>
+            </a:r>
+            <a:r>
+              <a:rPr lang="en-US" sz="1425" b="0" i="0" u="none" strike="noStrike" cap="none" dirty="0" err="1">
+                <a:solidFill>
+                  <a:srgbClr val="94A3B8"/>
+                </a:solidFill>
+                <a:latin typeface="Inter"/>
+                <a:ea typeface="Inter"/>
+                <a:cs typeface="Inter"/>
+                <a:sym typeface="Inter"/>
+              </a:rPr>
+              <a:t>mapea</a:t>
+            </a:r>
+            <a:r>
+              <a:rPr lang="en-US" sz="1425" b="0" i="0" u="none" strike="noStrike" cap="none" dirty="0">
+                <a:solidFill>
+                  <a:srgbClr val="94A3B8"/>
+                </a:solidFill>
+                <a:latin typeface="Inter"/>
+                <a:ea typeface="Inter"/>
+                <a:cs typeface="Inter"/>
+                <a:sym typeface="Inter"/>
+              </a:rPr>
+              <a:t> </a:t>
+            </a:r>
+            <a:r>
+              <a:rPr lang="en-US" sz="1425" b="0" i="0" u="none" strike="noStrike" cap="none" dirty="0" err="1">
+                <a:solidFill>
+                  <a:srgbClr val="94A3B8"/>
+                </a:solidFill>
+                <a:latin typeface="Inter"/>
+                <a:ea typeface="Inter"/>
+                <a:cs typeface="Inter"/>
+                <a:sym typeface="Inter"/>
+              </a:rPr>
+              <a:t>nuestros</a:t>
+            </a:r>
+            <a:r>
+              <a:rPr lang="en-US" sz="1425" b="0" i="0" u="none" strike="noStrike" cap="none" dirty="0">
+                <a:solidFill>
+                  <a:srgbClr val="94A3B8"/>
+                </a:solidFill>
+                <a:latin typeface="Inter"/>
+                <a:ea typeface="Inter"/>
+                <a:cs typeface="Inter"/>
+                <a:sym typeface="Inter"/>
+              </a:rPr>
+              <a:t> </a:t>
+            </a:r>
+            <a:r>
+              <a:rPr lang="en-US" sz="1425" b="0" i="0" u="none" strike="noStrike" cap="none" dirty="0" err="1">
+                <a:solidFill>
+                  <a:srgbClr val="94A3B8"/>
+                </a:solidFill>
+                <a:latin typeface="Inter"/>
+                <a:ea typeface="Inter"/>
+                <a:cs typeface="Inter"/>
+                <a:sym typeface="Inter"/>
+              </a:rPr>
+              <a:t>objetos</a:t>
+            </a:r>
+            <a:r>
+              <a:rPr lang="en-US" sz="1425" b="0" i="0" u="none" strike="noStrike" cap="none" dirty="0">
+                <a:solidFill>
+                  <a:srgbClr val="94A3B8"/>
+                </a:solidFill>
+                <a:latin typeface="Inter"/>
+                <a:ea typeface="Inter"/>
+                <a:cs typeface="Inter"/>
+                <a:sym typeface="Inter"/>
+              </a:rPr>
+              <a:t> Java a </a:t>
+            </a:r>
+            <a:r>
+              <a:rPr lang="en-US" sz="1425" b="0" i="0" u="none" strike="noStrike" cap="none" dirty="0" err="1">
+                <a:solidFill>
+                  <a:srgbClr val="94A3B8"/>
+                </a:solidFill>
+                <a:latin typeface="Inter"/>
+                <a:ea typeface="Inter"/>
+                <a:cs typeface="Inter"/>
+                <a:sym typeface="Inter"/>
+              </a:rPr>
+              <a:t>tablas</a:t>
+            </a:r>
+            <a:r>
+              <a:rPr lang="en-US" sz="1425" b="0" i="0" u="none" strike="noStrike" cap="none" dirty="0">
+                <a:solidFill>
+                  <a:srgbClr val="94A3B8"/>
+                </a:solidFill>
+                <a:latin typeface="Inter"/>
+                <a:ea typeface="Inter"/>
+                <a:cs typeface="Inter"/>
+                <a:sym typeface="Inter"/>
+              </a:rPr>
+              <a:t> SQL </a:t>
+            </a:r>
+            <a:r>
+              <a:rPr lang="en-US" sz="1425" b="0" i="0" u="none" strike="noStrike" cap="none" dirty="0" err="1">
+                <a:solidFill>
+                  <a:srgbClr val="94A3B8"/>
+                </a:solidFill>
+                <a:latin typeface="Inter"/>
+                <a:ea typeface="Inter"/>
+                <a:cs typeface="Inter"/>
+                <a:sym typeface="Inter"/>
+              </a:rPr>
+              <a:t>automáticamente</a:t>
+            </a:r>
+            <a:r>
+              <a:rPr lang="en-US" sz="1425" b="0" i="0" u="none" strike="noStrike" cap="none" dirty="0">
+                <a:solidFill>
+                  <a:srgbClr val="94A3B8"/>
+                </a:solidFill>
+                <a:latin typeface="Inter"/>
+                <a:ea typeface="Inter"/>
+                <a:cs typeface="Inter"/>
+                <a:sym typeface="Inter"/>
+              </a:rPr>
+              <a:t>, </a:t>
+            </a:r>
+            <a:r>
+              <a:rPr lang="en-US" sz="1425" b="0" i="0" u="none" strike="noStrike" cap="none" dirty="0" err="1">
+                <a:solidFill>
+                  <a:srgbClr val="94A3B8"/>
+                </a:solidFill>
+                <a:latin typeface="Inter"/>
+                <a:ea typeface="Inter"/>
+                <a:cs typeface="Inter"/>
+                <a:sym typeface="Inter"/>
+              </a:rPr>
+              <a:t>ahorrando</a:t>
+            </a:r>
+            <a:r>
+              <a:rPr lang="en-US" sz="1425" b="0" i="0" u="none" strike="noStrike" cap="none" dirty="0">
+                <a:solidFill>
+                  <a:srgbClr val="94A3B8"/>
+                </a:solidFill>
+                <a:latin typeface="Inter"/>
+                <a:ea typeface="Inter"/>
+                <a:cs typeface="Inter"/>
+                <a:sym typeface="Inter"/>
+              </a:rPr>
+              <a:t> </a:t>
+            </a:r>
+            <a:r>
+              <a:rPr lang="en-US" sz="1425" b="0" i="0" u="none" strike="noStrike" cap="none" dirty="0" err="1">
+                <a:solidFill>
+                  <a:srgbClr val="94A3B8"/>
+                </a:solidFill>
+                <a:latin typeface="Inter"/>
+                <a:ea typeface="Inter"/>
+                <a:cs typeface="Inter"/>
+                <a:sym typeface="Inter"/>
+              </a:rPr>
+              <a:t>código</a:t>
+            </a:r>
+            <a:r>
+              <a:rPr lang="en-US" sz="1425" b="0" i="0" u="none" strike="noStrike" cap="none" dirty="0">
+                <a:solidFill>
+                  <a:srgbClr val="94A3B8"/>
+                </a:solidFill>
+                <a:latin typeface="Inter"/>
+                <a:ea typeface="Inter"/>
+                <a:cs typeface="Inter"/>
+                <a:sym typeface="Inter"/>
+              </a:rPr>
+              <a:t> </a:t>
+            </a:r>
+            <a:r>
+              <a:rPr lang="en-US" sz="1425" b="0" i="0" u="none" strike="noStrike" cap="none" dirty="0" err="1">
+                <a:solidFill>
+                  <a:srgbClr val="94A3B8"/>
+                </a:solidFill>
+                <a:latin typeface="Inter"/>
+                <a:ea typeface="Inter"/>
+                <a:cs typeface="Inter"/>
+                <a:sym typeface="Inter"/>
+              </a:rPr>
+              <a:t>repetitivo</a:t>
+            </a:r>
+            <a:r>
+              <a:rPr lang="en-US" sz="1425" b="0" i="0" u="none" strike="noStrike" cap="none" dirty="0">
+                <a:solidFill>
+                  <a:srgbClr val="94A3B8"/>
+                </a:solidFill>
+                <a:latin typeface="Inter"/>
+                <a:ea typeface="Inter"/>
+                <a:cs typeface="Inter"/>
+                <a:sym typeface="Inter"/>
+              </a:rPr>
+              <a:t> (Boilerplate).</a:t>
+            </a:r>
+            <a:endParaRPr dirty="0"/>
           </a:p>
         </p:txBody>
       </p:sp>
@@ -15138,13 +15450,13 @@
   <p:clrMapOvr>
     <a:masterClrMapping/>
   </p:clrMapOvr>
-  <mc:AlternateContent xmlns:mc="http://schemas.openxmlformats.org/markup-compatibility/2006">
-    <mc:Choice xmlns:p14="http://schemas.microsoft.com/office/powerpoint/2010/main" Requires="p14">
+  <mc:AlternateContent xmlns:mc="http://schemas.openxmlformats.org/markup-compatibility/2006" xmlns:p14="http://schemas.microsoft.com/office/powerpoint/2010/main">
+    <mc:Choice Requires="p14">
       <p:transition spd="med" p14:dur="700">
         <p:fade/>
       </p:transition>
     </mc:Choice>
-    <mc:Fallback>
+    <mc:Fallback xmlns="">
       <p:transition spd="med">
         <p:fade/>
       </p:transition>
@@ -15976,13 +16288,13 @@
   <p:clrMapOvr>
     <a:masterClrMapping/>
   </p:clrMapOvr>
-  <mc:AlternateContent xmlns:mc="http://schemas.openxmlformats.org/markup-compatibility/2006">
-    <mc:Choice xmlns:p14="http://schemas.microsoft.com/office/powerpoint/2010/main" Requires="p14">
+  <mc:AlternateContent xmlns:mc="http://schemas.openxmlformats.org/markup-compatibility/2006" xmlns:p14="http://schemas.microsoft.com/office/powerpoint/2010/main">
+    <mc:Choice Requires="p14">
       <p:transition spd="med" p14:dur="700">
         <p:fade/>
       </p:transition>
     </mc:Choice>
-    <mc:Fallback>
+    <mc:Fallback xmlns="">
       <p:transition spd="med">
         <p:fade/>
       </p:transition>
@@ -17992,13 +18304,13 @@
   <p:clrMapOvr>
     <a:masterClrMapping/>
   </p:clrMapOvr>
-  <mc:AlternateContent xmlns:mc="http://schemas.openxmlformats.org/markup-compatibility/2006">
-    <mc:Choice xmlns:p14="http://schemas.microsoft.com/office/powerpoint/2010/main" Requires="p14">
+  <mc:AlternateContent xmlns:mc="http://schemas.openxmlformats.org/markup-compatibility/2006" xmlns:p14="http://schemas.microsoft.com/office/powerpoint/2010/main">
+    <mc:Choice Requires="p14">
       <p:transition spd="med" p14:dur="700">
         <p:fade/>
       </p:transition>
     </mc:Choice>
-    <mc:Fallback>
+    <mc:Fallback xmlns="">
       <p:transition spd="med">
         <p:fade/>
       </p:transition>
@@ -18759,13 +19071,13 @@
   <p:clrMapOvr>
     <a:masterClrMapping/>
   </p:clrMapOvr>
-  <mc:AlternateContent xmlns:mc="http://schemas.openxmlformats.org/markup-compatibility/2006">
-    <mc:Choice xmlns:p14="http://schemas.microsoft.com/office/powerpoint/2010/main" Requires="p14">
+  <mc:AlternateContent xmlns:mc="http://schemas.openxmlformats.org/markup-compatibility/2006" xmlns:p14="http://schemas.microsoft.com/office/powerpoint/2010/main">
+    <mc:Choice Requires="p14">
       <p:transition spd="med" p14:dur="700">
         <p:fade/>
       </p:transition>
     </mc:Choice>
-    <mc:Fallback>
+    <mc:Fallback xmlns="">
       <p:transition spd="med">
         <p:fade/>
       </p:transition>
@@ -19110,7 +19422,7 @@
         <p:spPr>
           <a:xfrm>
             <a:off x="6477000" y="3951833"/>
-            <a:ext cx="4991100" cy="781050"/>
+            <a:ext cx="4991100" cy="923330"/>
           </a:xfrm>
           <a:prstGeom prst="rect">
             <a:avLst/>
@@ -19126,17 +19438,9 @@
           </a:bodyPr>
           <a:lstStyle/>
           <a:p>
-            <a:pPr marL="0" marR="0" lvl="0" indent="0" algn="l" rtl="0">
-              <a:spcBef>
-                <a:spcPts val="0"/>
-              </a:spcBef>
-              <a:spcAft>
-                <a:spcPts val="0"/>
-              </a:spcAft>
-              <a:buNone/>
-            </a:pPr>
-            <a:r>
-              <a:rPr lang="en-US" sz="1200" b="0" i="0" u="none" strike="noStrike" cap="none">
+            <a:pPr lvl="0"/>
+            <a:r>
+              <a:rPr lang="en-US" sz="1200" b="0" i="0" u="none" strike="noStrike" cap="none" dirty="0" err="1">
                 <a:solidFill>
                   <a:schemeClr val="dk1"/>
                 </a:solidFill>
@@ -19145,10 +19449,46 @@
                 <a:cs typeface="Inter SemiBold"/>
                 <a:sym typeface="Inter SemiBold"/>
               </a:rPr>
-              <a:t>Solución Aplicada:</a:t>
-            </a:r>
-            <a:r>
-              <a:rPr lang="en-US" sz="1200" b="0" i="0" u="none" strike="noStrike" cap="none">
+              <a:t>Solución</a:t>
+            </a:r>
+            <a:r>
+              <a:rPr lang="en-US" sz="1200" b="0" i="0" u="none" strike="noStrike" cap="none" dirty="0">
+                <a:solidFill>
+                  <a:schemeClr val="dk1"/>
+                </a:solidFill>
+                <a:latin typeface="Inter SemiBold"/>
+                <a:ea typeface="Inter SemiBold"/>
+                <a:cs typeface="Inter SemiBold"/>
+                <a:sym typeface="Inter SemiBold"/>
+              </a:rPr>
+              <a:t> </a:t>
+            </a:r>
+            <a:r>
+              <a:rPr lang="en-US" sz="1200" b="0" i="0" u="none" strike="noStrike" cap="none" dirty="0" err="1">
+                <a:solidFill>
+                  <a:schemeClr val="dk1"/>
+                </a:solidFill>
+                <a:latin typeface="Inter SemiBold"/>
+                <a:ea typeface="Inter SemiBold"/>
+                <a:cs typeface="Inter SemiBold"/>
+                <a:sym typeface="Inter SemiBold"/>
+              </a:rPr>
+              <a:t>Aplicada</a:t>
+            </a:r>
+            <a:r>
+              <a:rPr lang="en-US" sz="1200" b="0" i="0" u="none" strike="noStrike" cap="none" dirty="0">
+                <a:solidFill>
+                  <a:schemeClr val="dk1"/>
+                </a:solidFill>
+                <a:latin typeface="Inter SemiBold"/>
+                <a:ea typeface="Inter SemiBold"/>
+                <a:cs typeface="Inter SemiBold"/>
+                <a:sym typeface="Inter SemiBold"/>
+              </a:rPr>
+              <a:t>:</a:t>
+            </a:r>
+            <a:r>
+              <a:rPr lang="en-US" sz="1200" b="0" i="0" u="none" strike="noStrike" cap="none" dirty="0">
                 <a:solidFill>
                   <a:srgbClr val="F8FAFC"/>
                 </a:solidFill>
@@ -19160,7 +19500,7 @@
               <a:t> </a:t>
             </a:r>
             <a:br>
-              <a:rPr lang="en-US" sz="1800" b="0" i="0" u="none" strike="noStrike" cap="none">
+              <a:rPr lang="en-US" sz="1800" b="0" i="0" u="none" strike="noStrike" cap="none" dirty="0">
                 <a:solidFill>
                   <a:schemeClr val="dk1"/>
                 </a:solidFill>
@@ -19171,7 +19511,83 @@
               </a:rPr>
             </a:br>
             <a:r>
-              <a:rPr lang="en-US" sz="1200" b="0" i="0" u="none" strike="noStrike" cap="none">
+              <a:rPr lang="es-ES" sz="1200" b="0" i="0" u="none" strike="noStrike" cap="none" dirty="0">
+                <a:solidFill>
+                  <a:schemeClr val="bg1"/>
+                </a:solidFill>
+                <a:latin typeface="Calibri"/>
+                <a:ea typeface="Calibri"/>
+                <a:cs typeface="Calibri"/>
+                <a:sym typeface="Calibri"/>
+              </a:rPr>
+              <a:t>I</a:t>
+            </a:r>
+            <a:r>
+              <a:rPr lang="es-ES" sz="1200">
+                <a:solidFill>
+                  <a:schemeClr val="bg1"/>
+                </a:solidFill>
+              </a:rPr>
+              <a:t>mplementamos </a:t>
+            </a:r>
+            <a:r>
+              <a:rPr lang="es-ES" sz="1200" dirty="0">
+                <a:solidFill>
+                  <a:schemeClr val="bg1"/>
+                </a:solidFill>
+              </a:rPr>
+              <a:t>un modelo asíncrono basado en </a:t>
+            </a:r>
+            <a:r>
+              <a:rPr lang="es-ES" sz="1200" b="1" dirty="0">
+                <a:solidFill>
+                  <a:schemeClr val="bg1"/>
+                </a:solidFill>
+              </a:rPr>
+              <a:t>promesas</a:t>
+            </a:r>
+            <a:r>
+              <a:rPr lang="es-ES" sz="1200" dirty="0">
+                <a:solidFill>
+                  <a:schemeClr val="bg1"/>
+                </a:solidFill>
+              </a:rPr>
+              <a:t>, delegando la gestión de red al cliente nativo </a:t>
+            </a:r>
+            <a:r>
+              <a:rPr lang="es-ES" sz="1200" b="1" dirty="0" err="1">
+                <a:solidFill>
+                  <a:schemeClr val="bg1"/>
+                </a:solidFill>
+              </a:rPr>
+              <a:t>HttpClient</a:t>
+            </a:r>
+            <a:r>
+              <a:rPr lang="es-ES" sz="1200" dirty="0">
+                <a:solidFill>
+                  <a:schemeClr val="bg1"/>
+                </a:solidFill>
+              </a:rPr>
+              <a:t> mediante su método </a:t>
+            </a:r>
+            <a:r>
+              <a:rPr lang="es-ES" sz="1200" b="1" dirty="0" err="1">
+                <a:solidFill>
+                  <a:schemeClr val="bg1"/>
+                </a:solidFill>
+              </a:rPr>
+              <a:t>sendAsync</a:t>
+            </a:r>
+            <a:r>
+              <a:rPr lang="es-ES" sz="1200" b="1" dirty="0">
+                <a:solidFill>
+                  <a:schemeClr val="bg1"/>
+                </a:solidFill>
+              </a:rPr>
+              <a:t> </a:t>
+            </a:r>
+            <a:r>
+              <a:rPr lang="en-US" sz="1200" b="0" i="0" u="none" strike="noStrike" cap="none" dirty="0">
                 <a:solidFill>
                   <a:srgbClr val="F8FAFC"/>
                 </a:solidFill>
@@ -19180,9 +19596,177 @@
                 <a:cs typeface="Inter"/>
                 <a:sym typeface="Inter"/>
               </a:rPr>
-              <a:t> Implementación estricta de multithreading. Usamos Task para aislar las llamadas HTTP en hilos secundarios, y devolvimos los resultados de forma segura a la pantalla usando Platform.runLater().</a:t>
-            </a:r>
-            <a:endParaRPr/>
+              <a:t>y </a:t>
+            </a:r>
+            <a:r>
+              <a:rPr lang="en-US" sz="1200" b="0" i="0" u="none" strike="noStrike" cap="none" dirty="0" err="1">
+                <a:solidFill>
+                  <a:srgbClr val="F8FAFC"/>
+                </a:solidFill>
+                <a:latin typeface="Inter"/>
+                <a:ea typeface="Inter"/>
+                <a:cs typeface="Inter"/>
+                <a:sym typeface="Inter"/>
+              </a:rPr>
+              <a:t>devolvimos</a:t>
+            </a:r>
+            <a:r>
+              <a:rPr lang="en-US" sz="1200" b="0" i="0" u="none" strike="noStrike" cap="none" dirty="0">
+                <a:solidFill>
+                  <a:srgbClr val="F8FAFC"/>
+                </a:solidFill>
+                <a:latin typeface="Inter"/>
+                <a:ea typeface="Inter"/>
+                <a:cs typeface="Inter"/>
+                <a:sym typeface="Inter"/>
+              </a:rPr>
+              <a:t> </a:t>
+            </a:r>
+            <a:r>
+              <a:rPr lang="en-US" sz="1200" b="0" i="0" u="none" strike="noStrike" cap="none" dirty="0" err="1">
+                <a:solidFill>
+                  <a:srgbClr val="F8FAFC"/>
+                </a:solidFill>
+                <a:latin typeface="Inter"/>
+                <a:ea typeface="Inter"/>
+                <a:cs typeface="Inter"/>
+                <a:sym typeface="Inter"/>
+              </a:rPr>
+              <a:t>los</a:t>
+            </a:r>
+            <a:r>
+              <a:rPr lang="en-US" sz="1200" b="0" i="0" u="none" strike="noStrike" cap="none" dirty="0">
+                <a:solidFill>
+                  <a:srgbClr val="F8FAFC"/>
+                </a:solidFill>
+                <a:latin typeface="Inter"/>
+                <a:ea typeface="Inter"/>
+                <a:cs typeface="Inter"/>
+                <a:sym typeface="Inter"/>
+              </a:rPr>
+              <a:t> </a:t>
+            </a:r>
+            <a:r>
+              <a:rPr lang="en-US" sz="1200" b="0" i="0" u="none" strike="noStrike" cap="none" dirty="0" err="1">
+                <a:solidFill>
+                  <a:srgbClr val="F8FAFC"/>
+                </a:solidFill>
+                <a:latin typeface="Inter"/>
+                <a:ea typeface="Inter"/>
+                <a:cs typeface="Inter"/>
+                <a:sym typeface="Inter"/>
+              </a:rPr>
+              <a:t>resultados</a:t>
+            </a:r>
+            <a:r>
+              <a:rPr lang="en-US" sz="1200" b="0" i="0" u="none" strike="noStrike" cap="none" dirty="0">
+                <a:solidFill>
+                  <a:srgbClr val="F8FAFC"/>
+                </a:solidFill>
+                <a:latin typeface="Inter"/>
+                <a:ea typeface="Inter"/>
+                <a:cs typeface="Inter"/>
+                <a:sym typeface="Inter"/>
+              </a:rPr>
+              <a:t> de forma </a:t>
+            </a:r>
+            <a:r>
+              <a:rPr lang="en-US" sz="1200" b="0" i="0" u="none" strike="noStrike" cap="none" dirty="0" err="1">
+                <a:solidFill>
+                  <a:srgbClr val="F8FAFC"/>
+                </a:solidFill>
+                <a:latin typeface="Inter"/>
+                <a:ea typeface="Inter"/>
+                <a:cs typeface="Inter"/>
+                <a:sym typeface="Inter"/>
+              </a:rPr>
+              <a:t>segura</a:t>
+            </a:r>
+            <a:r>
+              <a:rPr lang="en-US" sz="1200" b="0" i="0" u="none" strike="noStrike" cap="none" dirty="0">
+                <a:solidFill>
+                  <a:srgbClr val="F8FAFC"/>
+                </a:solidFill>
+                <a:latin typeface="Inter"/>
+                <a:ea typeface="Inter"/>
+                <a:cs typeface="Inter"/>
+                <a:sym typeface="Inter"/>
+              </a:rPr>
+              <a:t> a la </a:t>
+            </a:r>
+            <a:r>
+              <a:rPr lang="en-US" sz="1200" b="0" i="0" u="none" strike="noStrike" cap="none" dirty="0" err="1">
+                <a:solidFill>
+                  <a:srgbClr val="F8FAFC"/>
+                </a:solidFill>
+                <a:latin typeface="Inter"/>
+                <a:ea typeface="Inter"/>
+                <a:cs typeface="Inter"/>
+                <a:sym typeface="Inter"/>
+              </a:rPr>
+              <a:t>pantalla</a:t>
+            </a:r>
+            <a:r>
+              <a:rPr lang="en-US" sz="1200" b="0" i="0" u="none" strike="noStrike" cap="none" dirty="0">
+                <a:solidFill>
+                  <a:srgbClr val="F8FAFC"/>
+                </a:solidFill>
+                <a:latin typeface="Inter"/>
+                <a:ea typeface="Inter"/>
+                <a:cs typeface="Inter"/>
+                <a:sym typeface="Inter"/>
+              </a:rPr>
+              <a:t> </a:t>
+            </a:r>
+            <a:r>
+              <a:rPr lang="en-US" sz="1200" b="0" i="0" u="none" strike="noStrike" cap="none" dirty="0" err="1">
+                <a:solidFill>
+                  <a:srgbClr val="F8FAFC"/>
+                </a:solidFill>
+                <a:latin typeface="Inter"/>
+                <a:ea typeface="Inter"/>
+                <a:cs typeface="Inter"/>
+                <a:sym typeface="Inter"/>
+              </a:rPr>
+              <a:t>usando</a:t>
+            </a:r>
+            <a:r>
+              <a:rPr lang="en-US" sz="1200" b="0" i="0" u="none" strike="noStrike" cap="none" dirty="0">
+                <a:solidFill>
+                  <a:srgbClr val="F8FAFC"/>
+                </a:solidFill>
+                <a:latin typeface="Inter"/>
+                <a:ea typeface="Inter"/>
+                <a:cs typeface="Inter"/>
+                <a:sym typeface="Inter"/>
+              </a:rPr>
+              <a:t> </a:t>
+            </a:r>
+            <a:r>
+              <a:rPr lang="en-US" sz="1200" b="0" i="0" u="none" strike="noStrike" cap="none" dirty="0" err="1">
+                <a:solidFill>
+                  <a:srgbClr val="F8FAFC"/>
+                </a:solidFill>
+                <a:latin typeface="Inter"/>
+                <a:ea typeface="Inter"/>
+                <a:cs typeface="Inter"/>
+                <a:sym typeface="Inter"/>
+              </a:rPr>
+              <a:t>Platform.runLater</a:t>
+            </a:r>
+            <a:r>
+              <a:rPr lang="en-US" sz="1200" b="0" i="0" u="none" strike="noStrike" cap="none" dirty="0">
+                <a:solidFill>
+                  <a:srgbClr val="F8FAFC"/>
+                </a:solidFill>
+                <a:latin typeface="Inter"/>
+                <a:ea typeface="Inter"/>
+                <a:cs typeface="Inter"/>
+                <a:sym typeface="Inter"/>
+              </a:rPr>
+              <a:t>().</a:t>
+            </a:r>
+            <a:endParaRPr dirty="0"/>
           </a:p>
         </p:txBody>
       </p:sp>
@@ -19502,13 +20086,13 @@
   <p:clrMapOvr>
     <a:masterClrMapping/>
   </p:clrMapOvr>
-  <mc:AlternateContent xmlns:mc="http://schemas.openxmlformats.org/markup-compatibility/2006">
-    <mc:Choice xmlns:p14="http://schemas.microsoft.com/office/powerpoint/2010/main" Requires="p14">
+  <mc:AlternateContent xmlns:mc="http://schemas.openxmlformats.org/markup-compatibility/2006" xmlns:p14="http://schemas.microsoft.com/office/powerpoint/2010/main">
+    <mc:Choice Requires="p14">
       <p:transition spd="med" p14:dur="700">
         <p:fade/>
       </p:transition>
     </mc:Choice>
-    <mc:Fallback>
+    <mc:Fallback xmlns="">
       <p:transition spd="med">
         <p:fade/>
       </p:transition>
@@ -20404,13 +20988,13 @@
   <p:clrMapOvr>
     <a:masterClrMapping/>
   </p:clrMapOvr>
-  <mc:AlternateContent xmlns:mc="http://schemas.openxmlformats.org/markup-compatibility/2006">
-    <mc:Choice xmlns:p14="http://schemas.microsoft.com/office/powerpoint/2010/main" Requires="p14">
+  <mc:AlternateContent xmlns:mc="http://schemas.openxmlformats.org/markup-compatibility/2006" xmlns:p14="http://schemas.microsoft.com/office/powerpoint/2010/main">
+    <mc:Choice Requires="p14">
       <p:transition spd="med" p14:dur="700">
         <p:fade/>
       </p:transition>
     </mc:Choice>
-    <mc:Fallback>
+    <mc:Fallback xmlns="">
       <p:transition spd="med">
         <p:fade/>
       </p:transition>
@@ -21015,13 +21599,13 @@
   <p:clrMapOvr>
     <a:masterClrMapping/>
   </p:clrMapOvr>
-  <mc:AlternateContent xmlns:mc="http://schemas.openxmlformats.org/markup-compatibility/2006">
-    <mc:Choice xmlns:p14="http://schemas.microsoft.com/office/powerpoint/2010/main" Requires="p14">
+  <mc:AlternateContent xmlns:mc="http://schemas.openxmlformats.org/markup-compatibility/2006" xmlns:p14="http://schemas.microsoft.com/office/powerpoint/2010/main">
+    <mc:Choice Requires="p14">
       <p:transition spd="med" p14:dur="700">
         <p:fade/>
       </p:transition>
     </mc:Choice>
-    <mc:Fallback>
+    <mc:Fallback xmlns="">
       <p:transition spd="med">
         <p:fade/>
       </p:transition>

</xml_diff>